<commit_message>
Fix code review issues: use Pt for font size and specific exceptions
Co-authored-by: dusturb <236991617+dusturb@users.noreply.github.com>
</commit_message>
<xml_diff>
--- a/presentation.pptx
+++ b/presentation.pptx
@@ -3174,7 +3174,7 @@
           <a:lstStyle/>
           <a:p>
             <a:pPr>
-              <a:defRPr sz="2880" b="1"/>
+              <a:defRPr sz="2800" b="1"/>
             </a:pPr>
             <a:r>
               <a:t>Claude Skill</a:t>
@@ -3247,7 +3247,7 @@
           <a:lstStyle/>
           <a:p>
             <a:pPr>
-              <a:defRPr sz="2880" b="1"/>
+              <a:defRPr sz="2800" b="1"/>
             </a:pPr>
             <a:r>
               <a:t>Mit License</a:t>
@@ -3320,7 +3320,7 @@
           <a:lstStyle/>
           <a:p>
             <a:pPr>
-              <a:defRPr sz="2880" b="1"/>
+              <a:defRPr sz="2800" b="1"/>
             </a:pPr>
             <a:r>
               <a:t>Star History</a:t>

</xml_diff>